<commit_message>
Codeblokken van Deel 7 pasten net niet meer
Door de uitleg-commentaren erbij werden de eerste twee blokken zeven regels
in een kader dat er zes aankan. De lege scheidingsregel eruit; nu past het.

Co-Authored-By: Claude Opus 5 <noreply@anthropic.com>
</commit_message>
<xml_diff>
--- a/powerpoints/Pokerbot_Upgrade_Week3.pptx
+++ b/powerpoints/Pokerbot_Upgrade_Week3.pptx
@@ -8615,19 +8615,6 @@
               </a:defRPr>
             </a:pPr>
             <a:r>
-              <a:t> </a:t>
-            </a:r>
-          </a:p>
-          <a:p>
-            <a:pPr>
-              <a:defRPr sz="900">
-                <a:solidFill>
-                  <a:srgbClr val="E8EEF4"/>
-                </a:solidFill>
-                <a:latin typeface="Consolas"/>
-              </a:defRPr>
-            </a:pPr>
-            <a:r>
               <a:t>winkans = schat_winkans(hand, tegenstanders=5)</a:t>
             </a:r>
           </a:p>
@@ -8753,7 +8740,7 @@
               </a:defRPr>
             </a:pPr>
             <a:r>
-              <a:t># zelfde idee, maar per straat een eigen getal</a:t>
+              <a:t># zelfde idee, per straat een eigen getal</a:t>
             </a:r>
           </a:p>
           <a:p>
@@ -8780,19 +8767,6 @@
             </a:pPr>
             <a:r>
               <a:t>         "turn": 35, "river": 30}</a:t>
-            </a:r>
-          </a:p>
-          <a:p>
-            <a:pPr>
-              <a:defRPr sz="900">
-                <a:solidFill>
-                  <a:srgbClr val="E8EEF4"/>
-                </a:solidFill>
-                <a:latin typeface="Consolas"/>
-              </a:defRPr>
-            </a:pPr>
-            <a:r>
-              <a:t> </a:t>
             </a:r>
           </a:p>
           <a:p>

</xml_diff>